<commit_message>
Update Week 1 Lecture 2 slide deck
Refreshes the Week 1 Lecture 2 materials by updating both the source PowerPoint file and its exported PDF in `docs/lecture_slides/Week 1/` so the downloadable and viewable versions stay in sync.
</commit_message>
<xml_diff>
--- a/docs/lecture_slides/Week 1/Week1_Lecture2_Slides_1_12_2024.pptx
+++ b/docs/lecture_slides/Week 1/Week1_Lecture2_Slides_1_12_2024.pptx
@@ -6117,7 +6117,7 @@
           <a:p>
             <a:r>
               <a:rPr lang="en-US" sz="5400"/>
-              <a:t>Example: Gallup Pool</a:t>
+              <a:t>Example: Gallup Poll</a:t>
             </a:r>
           </a:p>
         </p:txBody>
@@ -6140,8 +6140,8 @@
         </p:nvSpPr>
         <p:spPr>
           <a:xfrm>
-            <a:off x="572493" y="2071316"/>
-            <a:ext cx="6713552" cy="4119172"/>
+            <a:off x="572493" y="1905000"/>
+            <a:ext cx="6713552" cy="4572000"/>
           </a:xfrm>
         </p:spPr>
         <p:txBody>
@@ -6158,31 +6158,58 @@
           <a:p>
             <a:r>
               <a:rPr lang="en-US" sz="1900" dirty="0"/>
-              <a:t>In response to the spill, many activists called for an end to offshore drilling for oil. </a:t>
+              <a:t>In response to the spill, many activists called for an end to offshore drilling. Almost nine months later, turbulence in the Middle East pushed the price of oil to an all-time high.</a:t>
             </a:r>
           </a:p>
           <a:p>
             <a:r>
               <a:rPr lang="en-US" sz="1900" dirty="0"/>
-              <a:t>Almost nine months later, turbulence in the middle east caused the price of oil to surge to an all-time high. </a:t>
+              <a:t>In March 2011, Gallup conducted a survey and found that 60% of Americans favored offshore drilling as a means to reduce U.S. dependence on foreign oil.</a:t>
             </a:r>
           </a:p>
           <a:p>
             <a:r>
               <a:rPr lang="en-US" sz="1900" dirty="0"/>
-              <a:t>In March 2011, Gallup conducted a survey and found that 60% of Americans favored offshore drilling as means to reduce U.S dependence on foreign oil.</a:t>
-            </a:r>
-          </a:p>
-          <a:p>
-            <a:r>
-              <a:rPr lang="en-US" sz="1900" dirty="0"/>
-              <a:t>The poll was based on interviews with 1,021 adults aged 18 and older, living in the continental U.S, and selected using random digit dialing. </a:t>
+              <a:t>The poll interviewed 1,021 adults aged 18 and older in the continental U.S., selected by random digit dialing.</a:t>
             </a:r>
           </a:p>
           <a:p>
             <a:r>
               <a:rPr lang="en-US" sz="1900" b="1" dirty="0"/>
-              <a:t>What is the population under study, and what is the population parameter being estimated? What is the sample statistic ?</a:t>
+              <a:t>What is the population, and what parameter is being estimated?</a:t>
+            </a:r>
+          </a:p>
+          <a:p>
+            <a:pPr marL="342900" indent="0">
+              <a:buNone/>
+            </a:pPr>
+            <a:r>
+              <a:rPr lang="en-US" sz="1900" dirty="0">
+                <a:solidFill>
+                  <a:srgbClr val="FF0000"/>
+                </a:solidFill>
+              </a:rPr>
+              <a:t>All adults 18 and older in the continental U.S.; the parameter is p, the true proportion of them who favor offshore drilling.</a:t>
+            </a:r>
+          </a:p>
+          <a:p>
+            <a:pPr marL="342900" indent="-342900"/>
+            <a:r>
+              <a:rPr lang="en-US" sz="1900" b="1" dirty="0"/>
+              <a:t>What is the sample, and what is the statistic?</a:t>
+            </a:r>
+          </a:p>
+          <a:p>
+            <a:pPr marL="342900" indent="0">
+              <a:buNone/>
+            </a:pPr>
+            <a:r>
+              <a:rPr lang="en-US" sz="1900" dirty="0">
+                <a:solidFill>
+                  <a:srgbClr val="FF0000"/>
+                </a:solidFill>
+              </a:rPr>
+              <a:t>The 1,021 adults interviewed (n = 1,021); the statistic is p̂ = 0.60.</a:t>
             </a:r>
           </a:p>
         </p:txBody>
@@ -6235,6 +6262,134 @@
   <p:clrMapOvr>
     <a:masterClrMapping/>
   </p:clrMapOvr>
+  <p:timing>
+    <p:tnLst>
+      <p:par>
+        <p:cTn id="1" dur="indefinite" restart="never" nodeType="tmRoot">
+          <p:childTnLst>
+            <p:seq concurrent="1" nextAc="seek">
+              <p:cTn id="2" dur="indefinite" nodeType="mainSeq">
+                <p:childTnLst>
+                  <p:par>
+                    <p:cTn id="3" fill="hold">
+                      <p:stCondLst>
+                        <p:cond delay="indefinite"/>
+                      </p:stCondLst>
+                      <p:childTnLst>
+                        <p:par>
+                          <p:cTn id="4" fill="hold">
+                            <p:stCondLst>
+                              <p:cond delay="0"/>
+                            </p:stCondLst>
+                            <p:childTnLst>
+                              <p:par>
+                                <p:cTn id="5" presetID="1" presetClass="entr" presetSubtype="0" fill="hold" nodeType="clickEffect">
+                                  <p:stCondLst>
+                                    <p:cond delay="0"/>
+                                  </p:stCondLst>
+                                  <p:childTnLst>
+                                    <p:set>
+                                      <p:cBhvr>
+                                        <p:cTn id="6" dur="1" fill="hold">
+                                          <p:stCondLst>
+                                            <p:cond delay="0"/>
+                                          </p:stCondLst>
+                                        </p:cTn>
+                                        <p:tgtEl>
+                                          <p:spTgt spid="3">
+                                            <p:txEl>
+                                              <p:pRg st="6" end="6"/>
+                                            </p:txEl>
+                                          </p:spTgt>
+                                        </p:tgtEl>
+                                        <p:attrNameLst>
+                                          <p:attrName>style.visibility</p:attrName>
+                                        </p:attrNameLst>
+                                      </p:cBhvr>
+                                      <p:to>
+                                        <p:strVal val="visible"/>
+                                      </p:to>
+                                    </p:set>
+                                  </p:childTnLst>
+                                </p:cTn>
+                              </p:par>
+                            </p:childTnLst>
+                          </p:cTn>
+                        </p:par>
+                      </p:childTnLst>
+                    </p:cTn>
+                  </p:par>
+                  <p:par>
+                    <p:cTn id="7" fill="hold">
+                      <p:stCondLst>
+                        <p:cond delay="indefinite"/>
+                      </p:stCondLst>
+                      <p:childTnLst>
+                        <p:par>
+                          <p:cTn id="8" fill="hold">
+                            <p:stCondLst>
+                              <p:cond delay="0"/>
+                            </p:stCondLst>
+                            <p:childTnLst>
+                              <p:par>
+                                <p:cTn id="9" presetID="1" presetClass="entr" presetSubtype="0" fill="hold" nodeType="clickEffect">
+                                  <p:stCondLst>
+                                    <p:cond delay="0"/>
+                                  </p:stCondLst>
+                                  <p:childTnLst>
+                                    <p:set>
+                                      <p:cBhvr>
+                                        <p:cTn id="10" dur="1" fill="hold">
+                                          <p:stCondLst>
+                                            <p:cond delay="0"/>
+                                          </p:stCondLst>
+                                        </p:cTn>
+                                        <p:tgtEl>
+                                          <p:spTgt spid="3">
+                                            <p:txEl>
+                                              <p:pRg st="8" end="8"/>
+                                            </p:txEl>
+                                          </p:spTgt>
+                                        </p:tgtEl>
+                                        <p:attrNameLst>
+                                          <p:attrName>style.visibility</p:attrName>
+                                        </p:attrNameLst>
+                                      </p:cBhvr>
+                                      <p:to>
+                                        <p:strVal val="visible"/>
+                                      </p:to>
+                                    </p:set>
+                                  </p:childTnLst>
+                                </p:cTn>
+                              </p:par>
+                            </p:childTnLst>
+                          </p:cTn>
+                        </p:par>
+                      </p:childTnLst>
+                    </p:cTn>
+                  </p:par>
+                </p:childTnLst>
+              </p:cTn>
+              <p:prevCondLst>
+                <p:cond evt="onPrev" delay="0">
+                  <p:tgtEl>
+                    <p:sldTgt/>
+                  </p:tgtEl>
+                </p:cond>
+              </p:prevCondLst>
+              <p:nextCondLst>
+                <p:cond evt="onNext" delay="0">
+                  <p:tgtEl>
+                    <p:sldTgt/>
+                  </p:tgtEl>
+                </p:cond>
+              </p:nextCondLst>
+            </p:seq>
+          </p:childTnLst>
+        </p:cTn>
+      </p:par>
+    </p:tnLst>
+  </p:timing>
 </p:sld>
 </file>
 
@@ -6614,7 +6769,7 @@
                       <a:srgbClr val="FF0000"/>
                     </a:solidFill>
                   </a:rPr>
-                  <a:t>Who will win the California Race for Governor</a:t>
+                  <a:t>Who will win the California race for governor?</a:t>
                 </a:r>
               </a:p>
               <a:p>
@@ -6650,7 +6805,7 @@
                       <a:srgbClr val="FF0000"/>
                     </a:solidFill>
                   </a:rPr>
-                  <a:t>The population is all eligible voters in the state of California</a:t>
+                  <a:t>All Californians who actually voted – not everyone eligible. N is unknown that night.</a:t>
                 </a:r>
               </a:p>
               <a:p>
@@ -6659,7 +6814,7 @@
                 </a:pPr>
                 <a:r>
                   <a:rPr lang="en-US" sz="2000" dirty="0"/>
-                  <a:t>What is the sample ? What is the sample size </a:t>
+                  <a:t>What is the sample? What is the sample size </a:t>
                 </a:r>
                 <a14:m>
                   <m:oMath xmlns:m="http://schemas.openxmlformats.org/officeDocument/2006/math">
@@ -6686,7 +6841,7 @@
                       <a:srgbClr val="FF0000"/>
                     </a:solidFill>
                   </a:rPr>
-                  <a:t>All voters interviewed at the election booth; 3,889 people</a:t>
+                  <a:t>The 3,889 voters interviewed as they left the booth; n = 3,889.</a:t>
                 </a:r>
               </a:p>
               <a:p>
@@ -6708,7 +6863,7 @@
                       <a:srgbClr val="FF0000"/>
                     </a:solidFill>
                   </a:rPr>
-                  <a:t>The proportion of 3,889 voters casting their vote for Democrat Jerry Brown </a:t>
+                  <a:t>p̂ = 0.531, the proportion of those 3,889 who chose Brown.</a:t>
                 </a:r>
               </a:p>
             </p:txBody>
@@ -10021,7 +10176,7 @@
         </p:nvSpPr>
         <p:spPr>
           <a:xfrm>
-            <a:off x="306534" y="1612616"/>
+            <a:off x="306534" y="1362616"/>
             <a:ext cx="6382326" cy="5293757"/>
           </a:xfrm>
           <a:prstGeom prst="rect">
@@ -10144,7 +10299,7 @@
                 </a:solidFill>
                 <a:latin typeface="Calibri" panose="020F0502020204030204"/>
               </a:rPr>
-              <a:t>finite/countable</a:t>
+              <a:t>finite</a:t>
             </a:r>
             <a:r>
               <a:rPr lang="it-IT" sz="2000" dirty="0">
@@ -10153,7 +10308,7 @@
                 </a:solidFill>
                 <a:latin typeface="Calibri" panose="020F0502020204030204"/>
               </a:rPr>
-              <a:t>  (e.g. All employees at a company) or </a:t>
+              <a:t> (e.g. all employees at a company) or </a:t>
             </a:r>
             <a:r>
               <a:rPr lang="it-IT" sz="2000" i="1" dirty="0">
@@ -10171,7 +10326,7 @@
                 </a:solidFill>
                 <a:latin typeface="Calibri" panose="020F0502020204030204"/>
               </a:rPr>
-              <a:t> and potentially </a:t>
+              <a:t> and </a:t>
             </a:r>
             <a:r>
               <a:rPr lang="it-IT" sz="2000" i="1" dirty="0">
@@ -10180,7 +10335,7 @@
                 </a:solidFill>
                 <a:latin typeface="Calibri" panose="020F0502020204030204"/>
               </a:rPr>
-              <a:t>infinite/uncountable</a:t>
+              <a:t>unlimited</a:t>
             </a:r>
             <a:r>
               <a:rPr lang="it-IT" sz="2000" dirty="0">
@@ -10189,7 +10344,7 @@
                 </a:solidFill>
                 <a:latin typeface="Calibri" panose="020F0502020204030204"/>
               </a:rPr>
-              <a:t> (e.g all possible hands in a game of poker)</a:t>
+              <a:t> (e.g. every hand that could ever be dealt in poker – a process we can repeat indefinitely)</a:t>
             </a:r>
           </a:p>
           <a:p>
@@ -10612,6 +10767,174 @@
   <p:clrMapOvr>
     <a:masterClrMapping/>
   </p:clrMapOvr>
+  <p:timing>
+    <p:tnLst>
+      <p:par>
+        <p:cTn id="1" dur="indefinite" restart="never" nodeType="tmRoot">
+          <p:childTnLst>
+            <p:seq concurrent="1" nextAc="seek">
+              <p:cTn id="2" dur="indefinite" nodeType="mainSeq">
+                <p:childTnLst>
+                  <p:par>
+                    <p:cTn id="3" fill="hold">
+                      <p:stCondLst>
+                        <p:cond delay="indefinite"/>
+                      </p:stCondLst>
+                      <p:childTnLst>
+                        <p:par>
+                          <p:cTn id="4" fill="hold">
+                            <p:stCondLst>
+                              <p:cond delay="0"/>
+                            </p:stCondLst>
+                            <p:childTnLst>
+                              <p:par>
+                                <p:cTn id="5" presetID="1" presetClass="entr" presetSubtype="0" fill="hold" nodeType="clickEffect">
+                                  <p:stCondLst>
+                                    <p:cond delay="0"/>
+                                  </p:stCondLst>
+                                  <p:childTnLst>
+                                    <p:set>
+                                      <p:cBhvr>
+                                        <p:cTn id="6" dur="1" fill="hold">
+                                          <p:stCondLst>
+                                            <p:cond delay="0"/>
+                                          </p:stCondLst>
+                                        </p:cTn>
+                                        <p:tgtEl>
+                                          <p:spTgt spid="3">
+                                            <p:txEl>
+                                              <p:pRg st="4" end="4"/>
+                                            </p:txEl>
+                                          </p:spTgt>
+                                        </p:tgtEl>
+                                        <p:attrNameLst>
+                                          <p:attrName>style.visibility</p:attrName>
+                                        </p:attrNameLst>
+                                      </p:cBhvr>
+                                      <p:to>
+                                        <p:strVal val="visible"/>
+                                      </p:to>
+                                    </p:set>
+                                  </p:childTnLst>
+                                </p:cTn>
+                              </p:par>
+                              <p:par>
+                                <p:cTn id="7" presetID="1" presetClass="entr" presetSubtype="0" fill="hold" nodeType="withEffect">
+                                  <p:stCondLst>
+                                    <p:cond delay="0"/>
+                                  </p:stCondLst>
+                                  <p:childTnLst>
+                                    <p:set>
+                                      <p:cBhvr>
+                                        <p:cTn id="8" dur="1" fill="hold">
+                                          <p:stCondLst>
+                                            <p:cond delay="0"/>
+                                          </p:stCondLst>
+                                        </p:cTn>
+                                        <p:tgtEl>
+                                          <p:spTgt spid="3">
+                                            <p:txEl>
+                                              <p:pRg st="5" end="5"/>
+                                            </p:txEl>
+                                          </p:spTgt>
+                                        </p:tgtEl>
+                                        <p:attrNameLst>
+                                          <p:attrName>style.visibility</p:attrName>
+                                        </p:attrNameLst>
+                                      </p:cBhvr>
+                                      <p:to>
+                                        <p:strVal val="visible"/>
+                                      </p:to>
+                                    </p:set>
+                                  </p:childTnLst>
+                                </p:cTn>
+                              </p:par>
+                              <p:par>
+                                <p:cTn id="9" presetID="1" presetClass="entr" presetSubtype="0" fill="hold" nodeType="withEffect">
+                                  <p:stCondLst>
+                                    <p:cond delay="0"/>
+                                  </p:stCondLst>
+                                  <p:childTnLst>
+                                    <p:set>
+                                      <p:cBhvr>
+                                        <p:cTn id="10" dur="1" fill="hold">
+                                          <p:stCondLst>
+                                            <p:cond delay="0"/>
+                                          </p:stCondLst>
+                                        </p:cTn>
+                                        <p:tgtEl>
+                                          <p:spTgt spid="3">
+                                            <p:txEl>
+                                              <p:pRg st="6" end="6"/>
+                                            </p:txEl>
+                                          </p:spTgt>
+                                        </p:tgtEl>
+                                        <p:attrNameLst>
+                                          <p:attrName>style.visibility</p:attrName>
+                                        </p:attrNameLst>
+                                      </p:cBhvr>
+                                      <p:to>
+                                        <p:strVal val="visible"/>
+                                      </p:to>
+                                    </p:set>
+                                  </p:childTnLst>
+                                </p:cTn>
+                              </p:par>
+                              <p:par>
+                                <p:cTn id="11" presetID="1" presetClass="entr" presetSubtype="0" fill="hold" nodeType="withEffect">
+                                  <p:stCondLst>
+                                    <p:cond delay="0"/>
+                                  </p:stCondLst>
+                                  <p:childTnLst>
+                                    <p:set>
+                                      <p:cBhvr>
+                                        <p:cTn id="12" dur="1" fill="hold">
+                                          <p:stCondLst>
+                                            <p:cond delay="0"/>
+                                          </p:stCondLst>
+                                        </p:cTn>
+                                        <p:tgtEl>
+                                          <p:spTgt spid="4"/>
+                                        </p:tgtEl>
+                                        <p:attrNameLst>
+                                          <p:attrName>style.visibility</p:attrName>
+                                        </p:attrNameLst>
+                                      </p:cBhvr>
+                                      <p:to>
+                                        <p:strVal val="visible"/>
+                                      </p:to>
+                                    </p:set>
+                                  </p:childTnLst>
+                                </p:cTn>
+                              </p:par>
+                            </p:childTnLst>
+                          </p:cTn>
+                        </p:par>
+                      </p:childTnLst>
+                    </p:cTn>
+                  </p:par>
+                </p:childTnLst>
+              </p:cTn>
+              <p:prevCondLst>
+                <p:cond evt="onPrev" delay="0">
+                  <p:tgtEl>
+                    <p:sldTgt/>
+                  </p:tgtEl>
+                </p:cond>
+              </p:prevCondLst>
+              <p:nextCondLst>
+                <p:cond evt="onNext" delay="0">
+                  <p:tgtEl>
+                    <p:sldTgt/>
+                  </p:tgtEl>
+                </p:cond>
+              </p:nextCondLst>
+            </p:seq>
+          </p:childTnLst>
+        </p:cTn>
+      </p:par>
+    </p:tnLst>
+  </p:timing>
 </p:sld>
 </file>
 
@@ -11093,8 +11416,8 @@
           </p:sp>
         </mc:Fallback>
       </mc:AlternateContent>
-      <mc:AlternateContent xmlns:mc="http://schemas.openxmlformats.org/markup-compatibility/2006">
-        <mc:Choice xmlns:a14="http://schemas.microsoft.com/office/drawing/2010/main" Requires="a14">
+      <mc:AlternateContent xmlns:mc="http://schemas.openxmlformats.org/markup-compatibility/2006" xmlns:a14="http://schemas.microsoft.com/office/drawing/2010/main">
+        <mc:Choice Requires="a14">
           <p:sp>
             <p:nvSpPr>
               <p:cNvPr id="19" name="TextBox 18">
@@ -11148,7 +11471,7 @@
             </p:txBody>
           </p:sp>
         </mc:Choice>
-        <mc:Fallback>
+        <mc:Fallback xmlns="">
           <p:sp>
             <p:nvSpPr>
               <p:cNvPr id="19" name="TextBox 18">

</xml_diff>